<commit_message>
Add Quincy reports PDF and update Module 3
Add the combined Quincy daily reports PDF and update Module 3 lesson content, slides, and activity/module metadata. Changes include: adding public/downloads/quincy-daily-reports.pdf; expanding lesson text and slide decks to use the Quincy PDF as the source document; updating lib/activity-data.ts and lib/module-data.ts with a new exercise (download + summarize the PDF), example outputs, an expanded rubric, and a longer estimated duration. Also modify markdownToHtml to add a download attribute for links under /downloads/ so PDFs save directly, update the slide generator script to reflect the new deck/timing/copy, and regenerate multiple PPTX slide binaries.
</commit_message>
<xml_diff>
--- a/docs/video-scripts/slides/pptx/module-3/lesson-3-2-rewriting-editing.pptx
+++ b/docs/video-scripts/slides/pptx/module-3/lesson-3-2-rewriting-editing.pptx
@@ -7,6 +7,7 @@
   <p:sldIdLst>
     <p:sldId id="256" r:id="rId7"/>
     <p:sldId id="257" r:id="rId8"/>
+    <p:sldId id="258" r:id="rId9"/>
   </p:sldIdLst>
   <p:sldSz cx="14630400" cy="8229600" type="screen4x3"/>
   <p:notesSz cx="6858000" cy="9144000"/>
@@ -3214,7 +3215,7 @@
                 </a:solidFill>
                 <a:latin typeface="Petrona"/>
               </a:rPr>
-              <a:t>Rewriting and Editing</a:t>
+              <a:t>Summarize the Quincy Reports</a:t>
             </a:r>
           </a:p>
         </p:txBody>
@@ -3253,7 +3254,7 @@
                 </a:solidFill>
                 <a:latin typeface="Inter"/>
               </a:rPr>
-              <a:t>Take a rough draft. Make it shine.</a:t>
+              <a:t>Real Cashman daily reports. Nine weeks. One PDF.</a:t>
             </a:r>
           </a:p>
         </p:txBody>
@@ -3357,7 +3358,7 @@
                 </a:solidFill>
                 <a:latin typeface="Inter"/>
               </a:rPr>
-              <a:t>THE SKILL</a:t>
+              <a:t>THE TASK</a:t>
             </a:r>
           </a:p>
         </p:txBody>
@@ -3396,7 +3397,7 @@
                 </a:solidFill>
                 <a:latin typeface="Petrona"/>
               </a:rPr>
-              <a:t>Source-grounding</a:t>
+              <a:t>Executive summary + thematic insights</a:t>
             </a:r>
           </a:p>
         </p:txBody>
@@ -3479,7 +3480,7 @@
                 </a:solidFill>
                 <a:latin typeface="Inter"/>
               </a:rPr>
-              <a:t>Tell AI exactly who the audience is.</a:t>
+              <a:t>•  PDF spans Dec 30, 2006 → Mar 5, 2007 (~9 weeks).</a:t>
             </a:r>
           </a:p>
           <a:p>
@@ -3495,7 +3496,7 @@
                 </a:solidFill>
                 <a:latin typeface="Inter"/>
               </a:rPr>
-              <a:t>Compare the rewrite to the original side by side.</a:t>
+              <a:t>•  Word files extracted, combined into one PDF for AI.</a:t>
             </a:r>
           </a:p>
           <a:p>
@@ -3511,7 +3512,254 @@
                 </a:solidFill>
                 <a:latin typeface="Inter"/>
               </a:rPr>
-              <a:t>Anything new = suspect. Verify or remove.</a:t>
+              <a:t>•  Summarize the season. Group insights by theme.</a:t>
+            </a:r>
+          </a:p>
+        </p:txBody>
+      </p:sp>
+    </p:spTree>
+  </p:cSld>
+  <p:clrMapOvr>
+    <a:masterClrMapping/>
+  </p:clrMapOvr>
+</p:sld>
+</file>
+
+<file path=ppt/slides/slide3.xml><?xml version="1.0" encoding="utf-8"?>
+<p:sld xmlns:a="http://schemas.openxmlformats.org/drawingml/2006/main" xmlns:p="http://schemas.openxmlformats.org/presentationml/2006/main" xmlns:r="http://schemas.openxmlformats.org/officeDocument/2006/relationships">
+  <p:cSld>
+    <p:bg>
+      <p:bgPr>
+        <a:solidFill>
+          <a:srgbClr val="FDFAF7"/>
+        </a:solidFill>
+        <a:effectLst/>
+      </p:bgPr>
+    </p:bg>
+    <p:spTree>
+      <p:nvGrpSpPr>
+        <p:cNvPr id="1" name=""/>
+        <p:cNvGrpSpPr/>
+        <p:nvPr/>
+      </p:nvGrpSpPr>
+      <p:grpSpPr/>
+      <p:sp>
+        <p:nvSpPr>
+          <p:cNvPr id="2" name="TextBox 1"/>
+          <p:cNvSpPr txBox="1"/>
+          <p:nvPr/>
+        </p:nvSpPr>
+        <p:spPr>
+          <a:xfrm>
+            <a:off x="795528" y="822960"/>
+            <a:ext cx="9262872" cy="365760"/>
+          </a:xfrm>
+          <a:prstGeom prst="rect">
+            <a:avLst/>
+          </a:prstGeom>
+          <a:noFill/>
+        </p:spPr>
+        <p:txBody>
+          <a:bodyPr wrap="square" lIns="0" rIns="0" tIns="0" bIns="0" anchor="t">
+            <a:spAutoFit/>
+          </a:bodyPr>
+          <a:lstStyle/>
+          <a:p>
+            <a:pPr algn="l">
+              <a:lnSpc>
+                <a:spcPct val="115000"/>
+              </a:lnSpc>
+            </a:pPr>
+            <a:r>
+              <a:rPr sz="1200" b="1">
+                <a:solidFill>
+                  <a:srgbClr val="2B6E2B"/>
+                </a:solidFill>
+                <a:latin typeface="Inter"/>
+              </a:rPr>
+              <a:t>THE DISCIPLINE</a:t>
+            </a:r>
+          </a:p>
+        </p:txBody>
+      </p:sp>
+      <p:sp>
+        <p:nvSpPr>
+          <p:cNvPr id="3" name="TextBox 2"/>
+          <p:cNvSpPr txBox="1"/>
+          <p:nvPr/>
+        </p:nvSpPr>
+        <p:spPr>
+          <a:xfrm>
+            <a:off x="795528" y="1280160"/>
+            <a:ext cx="9262872" cy="1828800"/>
+          </a:xfrm>
+          <a:prstGeom prst="rect">
+            <a:avLst/>
+          </a:prstGeom>
+          <a:noFill/>
+        </p:spPr>
+        <p:txBody>
+          <a:bodyPr wrap="square" lIns="0" rIns="0" tIns="0" bIns="0" anchor="t">
+            <a:spAutoFit/>
+          </a:bodyPr>
+          <a:lstStyle/>
+          <a:p>
+            <a:pPr algn="l">
+              <a:lnSpc>
+                <a:spcPct val="110000"/>
+              </a:lnSpc>
+            </a:pPr>
+            <a:r>
+              <a:rPr sz="4200" b="1">
+                <a:solidFill>
+                  <a:srgbClr val="030303"/>
+                </a:solidFill>
+                <a:latin typeface="Petrona"/>
+              </a:rPr>
+              <a:t>Source-grounding</a:t>
+            </a:r>
+          </a:p>
+        </p:txBody>
+      </p:sp>
+      <p:sp>
+        <p:nvSpPr>
+          <p:cNvPr id="4" name="Rectangle 3"/>
+          <p:cNvSpPr/>
+          <p:nvPr/>
+        </p:nvSpPr>
+        <p:spPr>
+          <a:xfrm>
+            <a:off x="795528" y="3840480"/>
+            <a:ext cx="9262872" cy="2377440"/>
+          </a:xfrm>
+          <a:prstGeom prst="rect">
+            <a:avLst/>
+          </a:prstGeom>
+          <a:solidFill>
+            <a:srgbClr val="C8E9C8"/>
+          </a:solidFill>
+          <a:ln>
+            <a:noFill/>
+          </a:ln>
+          <a:effectLst/>
+        </p:spPr>
+        <p:style>
+          <a:lnRef idx="1">
+            <a:schemeClr val="accent1"/>
+          </a:lnRef>
+          <a:fillRef idx="3">
+            <a:schemeClr val="accent1"/>
+          </a:fillRef>
+          <a:effectRef idx="2">
+            <a:schemeClr val="accent1"/>
+          </a:effectRef>
+          <a:fontRef idx="minor">
+            <a:schemeClr val="lt1"/>
+          </a:fontRef>
+        </p:style>
+        <p:txBody>
+          <a:bodyPr rtlCol="0" anchor="ctr"/>
+          <a:lstStyle/>
+          <a:p>
+            <a:pPr algn="ctr"/>
+          </a:p>
+        </p:txBody>
+      </p:sp>
+      <p:sp>
+        <p:nvSpPr>
+          <p:cNvPr id="5" name="Rectangle 4"/>
+          <p:cNvSpPr/>
+          <p:nvPr/>
+        </p:nvSpPr>
+        <p:spPr>
+          <a:xfrm>
+            <a:off x="758952" y="3840480"/>
+            <a:ext cx="118872" cy="2377440"/>
+          </a:xfrm>
+          <a:prstGeom prst="rect">
+            <a:avLst/>
+          </a:prstGeom>
+          <a:solidFill>
+            <a:srgbClr val="2B6E2B"/>
+          </a:solidFill>
+          <a:ln>
+            <a:noFill/>
+          </a:ln>
+          <a:effectLst/>
+        </p:spPr>
+        <p:style>
+          <a:lnRef idx="1">
+            <a:schemeClr val="accent1"/>
+          </a:lnRef>
+          <a:fillRef idx="3">
+            <a:schemeClr val="accent1"/>
+          </a:fillRef>
+          <a:effectRef idx="2">
+            <a:schemeClr val="accent1"/>
+          </a:effectRef>
+          <a:fontRef idx="minor">
+            <a:schemeClr val="lt1"/>
+          </a:fontRef>
+        </p:style>
+        <p:txBody>
+          <a:bodyPr rtlCol="0" anchor="ctr"/>
+          <a:lstStyle/>
+          <a:p>
+            <a:pPr algn="ctr"/>
+          </a:p>
+        </p:txBody>
+      </p:sp>
+      <p:sp>
+        <p:nvSpPr>
+          <p:cNvPr id="6" name="TextBox 5"/>
+          <p:cNvSpPr txBox="1"/>
+          <p:nvPr/>
+        </p:nvSpPr>
+        <p:spPr>
+          <a:xfrm>
+            <a:off x="1161288" y="4160520"/>
+            <a:ext cx="8531352" cy="1737360"/>
+          </a:xfrm>
+          <a:prstGeom prst="rect">
+            <a:avLst/>
+          </a:prstGeom>
+          <a:noFill/>
+        </p:spPr>
+        <p:txBody>
+          <a:bodyPr wrap="square" lIns="0" rIns="0" tIns="0" bIns="0" anchor="ctr">
+            <a:spAutoFit/>
+          </a:bodyPr>
+          <a:lstStyle/>
+          <a:p>
+            <a:pPr algn="l">
+              <a:lnSpc>
+                <a:spcPct val="125000"/>
+              </a:lnSpc>
+            </a:pPr>
+            <a:r>
+              <a:rPr sz="2600" b="1">
+                <a:solidFill>
+                  <a:srgbClr val="030303"/>
+                </a:solidFill>
+                <a:latin typeface="Petrona"/>
+              </a:rPr>
+              <a:t>Daily reports are full of specific facts.</a:t>
+            </a:r>
+          </a:p>
+          <a:p>
+            <a:pPr algn="l">
+              <a:lnSpc>
+                <a:spcPct val="125000"/>
+              </a:lnSpc>
+            </a:pPr>
+            <a:r>
+              <a:rPr sz="2600" b="1">
+                <a:solidFill>
+                  <a:srgbClr val="030303"/>
+                </a:solidFill>
+                <a:latin typeface="Petrona"/>
+              </a:rPr>
+              <a:t>Verify every name, number, and date AI cites — back to the source.</a:t>
             </a:r>
           </a:p>
         </p:txBody>

</xml_diff>